<commit_message>
fix: refine day 03 Streamlit RAG guidance
</commit_message>
<xml_diff>
--- a/course/day-03/instructor/slides/day-03-generative-ai-text-analysis.pptx
+++ b/course/day-03/instructor/slides/day-03-generative-ai-text-analysis.pptx
@@ -876,7 +876,7 @@
             <a:r>
               <a:rPr lang="en-US" dirty="0"/>
               <a:t>講師關鍵句：介面在資料與索引完成後才建立；學生要核對的是找回的 evidence 是否支撐回答。
-學生動作：依提示詞 05-1 到 05-3 建立 Streamlit 介面，再接上自己的向量索引。</a:t>
+學生動作：依提示詞 05-1 到 05-4 建立 Streamlit 介面，再接上自己的向量索引。</a:t>
             </a:r>
             <a:endParaRPr lang="en-US" dirty="0"/>
           </a:p>
@@ -12383,7 +12383,7 @@
                 <a:ea typeface="Noto Sans TC" pitchFamily="34" charset="-122"/>
                 <a:cs typeface="Noto Sans TC" pitchFamily="34" charset="-120"/>
               </a:rPr>
-              <a:t>操作 05 · 04-BUILD-CITED-RAG</a:t>
+              <a:t>操作 05 · 05-1 → 05-4</a:t>
             </a:r>
             <a:endParaRPr lang="en-US" sz="1000" dirty="0"/>
           </a:p>

</xml_diff>

<commit_message>
feat(day-03): make curriculum analysis-first
</commit_message>
<xml_diff>
--- a/course/day-03/instructor/slides/day-03-generative-ai-text-analysis.pptx
+++ b/course/day-03/instructor/slides/day-03-generative-ai-text-analysis.pptx
@@ -519,8 +519,8 @@
           <a:p>
             <a:r>
               <a:rPr lang="en-US" dirty="0"/>
-              <a:t>講師關鍵句：今天的重點不是做一個聊天機器人，而是讓每個答案都能回到資料來源。
-學生動作：打開課程 repo，確認已 clone Day-03 資料夾。</a:t>
+              <a:t>講師關鍵句：今天的重點不是做一個聊天機器人，而是讓 AI 的解讀與每個答案都能回到資料來源。
+學生動作：下載工作坊 ZIP，開啟 course/day-03/starter。</a:t>
             </a:r>
             <a:endParaRPr lang="en-US" dirty="0"/>
           </a:p>
@@ -876,7 +876,7 @@
             <a:r>
               <a:rPr lang="en-US" dirty="0"/>
               <a:t>講師關鍵句：介面在資料與索引完成後才建立；學生要核對的是找回的 evidence 是否支撐回答。
-學生動作：依提示詞 05-1 到 05-4 建立 Streamlit 介面，再接上自己的向量索引。</a:t>
+學生動作：依提示詞 5 建立 Streamlit 介面，再接上自己的向量索引。</a:t>
             </a:r>
             <a:endParaRPr lang="en-US" dirty="0"/>
           </a:p>
@@ -1232,7 +1232,7 @@
             <a:r>
               <a:rPr lang="en-US" dirty="0"/>
               <a:t>講師關鍵句：改善不是憑感覺調 prompt；每一項 backlog 都要回連 query_id 和證據。
-學生動作：貼上提示詞 07-1，將自我測試紀錄分類為可執行的改善動作。</a:t>
+學生動作：從問答紀錄回顧哪些題目需要補資料、修解析、調整切分或改善檢索。</a:t>
             </a:r>
             <a:endParaRPr lang="en-US" dirty="0"/>
           </a:p>
@@ -1409,8 +1409,8 @@
           <a:p>
             <a:r>
               <a:rPr lang="en-US" dirty="0"/>
-              <a:t>講師關鍵句：今天不是先做聊天畫面；要先把自己的校務資料變成可用索引。
-學生動作：確認今天的最終成果是自己的本機問答助手。</a:t>
+              <a:t>講師關鍵句：今天不是先做聊天畫面；先讓 AI 協助讀懂並整理文件。
+學生動作：確認今天有兩個成果：分析表和可引用問答助手。</a:t>
             </a:r>
             <a:endParaRPr lang="en-US" dirty="0"/>
           </a:p>
@@ -1587,7 +1587,7 @@
           <a:p>
             <a:r>
               <a:rPr lang="en-US" dirty="0"/>
-              <a:t>講師關鍵句：學生不會得到一個已完成的聊天室；資料處理完成後，才用 Codex 建立它。
+              <a:t>講師關鍵句：學生不會得到一個已完成的聊天室；先完成分析表，才用 Codex 建立它。
 學生動作：說出今天的四段順序。</a:t>
             </a:r>
             <a:endParaRPr lang="en-US" dirty="0"/>
@@ -1854,8 +1854,8 @@
           <a:p>
             <a:r>
               <a:rPr lang="en-US" dirty="0"/>
-              <a:t>講師關鍵句：學生不選網址；直接使用課程指定的四份公開資料，降低新手操作負擔。
-學生動作：貼上提示詞 02-1、02-2，建立個人資料夾與固定 scope。</a:t>
+              <a:t>講師關鍵句：學生不選網址，也不下載資料；先讀來源紀錄，知道每份文件從哪裡來。
+學生動作：貼上提示詞 1，確認環境與四份來源檔。</a:t>
             </a:r>
             <a:endParaRPr lang="en-US" dirty="0"/>
           </a:p>
@@ -1943,8 +1943,8 @@
           <a:p>
             <a:r>
               <a:rPr lang="en-US" dirty="0"/>
-              <a:t>講師關鍵句：學生只貼一個批次提示詞；Codex 仍必須逐份確認、處理並記錄失敗原因。
-學生動作：貼上提示詞 03，完成四份指定資料的結果表。</a:t>
+              <a:t>講師關鍵句：原始檔已準備好；學生只做本機轉換與品質判讀，不重做網頁蒐集。
+學生動作：貼上提示詞 2，完成四份文件的轉換與品質結果。</a:t>
             </a:r>
             <a:endParaRPr lang="en-US" dirty="0"/>
           </a:p>
@@ -2032,8 +2032,8 @@
           <a:p>
             <a:r>
               <a:rPr lang="en-US" dirty="0"/>
-              <a:t>講師關鍵句：此時才實際確認 MarkItDown MCP，因為我們已經有一份可解析的檔案。
-學生動作：提示詞 03 已批次完成取得、解析與品質檢查；講師帶學生核對任一成功來源的 raw、Markdown 與品質結果。</a:t>
+              <a:t>講師關鍵句：生成式 AI 的價值是協助閱讀與分類，不是取代來源或補造規定。
+學生動作：貼上提示詞 3，建立含來源段落的校務文件分析表。</a:t>
             </a:r>
             <a:endParaRPr lang="en-US" dirty="0"/>
           </a:p>
@@ -3397,7 +3397,7 @@
       </p:sp>
       <p:pic>
         <p:nvPicPr>
-          <p:cNvPr id="45" name="Image 0" descr="/Users/tzu/專案/GitHub/20260803-Workshop/course/day-03/instructor/slides/assets/meda-logo.png">    </p:cNvPr>
+          <p:cNvPr id="45" name="Image 0" descr="/private/tmp/20260803-Workshop-day03-analysis-first/course/day-03/instructor/slides/assets/meda-logo.png">    </p:cNvPr>
           <p:cNvPicPr>
             <a:picLocks noChangeAspect="1"/>
           </p:cNvPicPr>
@@ -3641,7 +3641,7 @@
                 <a:ea typeface="Noto Sans TC" pitchFamily="34" charset="-122"/>
                 <a:cs typeface="Noto Sans TC" pitchFamily="34" charset="-120"/>
               </a:rPr>
-              <a:t>先完成校務資料與索引，再用 Codex 做出自己的問答助手</a:t>
+              <a:t>先用生成式 AI 分析校務文件，再用問答助手驗證解讀</a:t>
             </a:r>
             <a:endParaRPr lang="en-US" sz="2000" dirty="0"/>
           </a:p>
@@ -3711,7 +3711,7 @@
                 <a:ea typeface="Noto Sans TC" pitchFamily="34" charset="-122"/>
                 <a:cs typeface="Noto Sans TC" pitchFamily="34" charset="-120"/>
               </a:rPr>
-              <a:t>指定資料</a:t>
+              <a:t>四份原始文件</a:t>
             </a:r>
             <a:endParaRPr lang="en-US" sz="1800" dirty="0"/>
           </a:p>
@@ -3822,7 +3822,7 @@
                 <a:ea typeface="Noto Sans TC" pitchFamily="34" charset="-122"/>
                 <a:cs typeface="Noto Sans TC" pitchFamily="34" charset="-120"/>
               </a:rPr>
-              <a:t>處理與索引</a:t>
+              <a:t>文件分析表</a:t>
             </a:r>
             <a:endParaRPr lang="en-US" sz="1800" dirty="0"/>
           </a:p>
@@ -3933,7 +3933,7 @@
                 <a:ea typeface="Noto Sans TC" pitchFamily="34" charset="-122"/>
                 <a:cs typeface="Noto Sans TC" pitchFamily="34" charset="-120"/>
               </a:rPr>
-              <a:t>Streamlit 介面</a:t>
+              <a:t>搜尋索引</a:t>
             </a:r>
             <a:endParaRPr lang="en-US" sz="1800" dirty="0"/>
           </a:p>
@@ -5114,7 +5114,7 @@
       </p:sp>
       <p:pic>
         <p:nvPicPr>
-          <p:cNvPr id="45" name="Image 0" descr="/Users/tzu/專案/GitHub/20260803-Workshop/course/day-03/instructor/slides/assets/meda-logo.png">    </p:cNvPr>
+          <p:cNvPr id="45" name="Image 0" descr="/private/tmp/20260803-Workshop-day03-analysis-first/course/day-03/instructor/slides/assets/meda-logo.png">    </p:cNvPr>
           <p:cNvPicPr>
             <a:picLocks noChangeAspect="1"/>
           </p:cNvPicPr>
@@ -7249,7 +7249,7 @@
       </p:sp>
       <p:pic>
         <p:nvPicPr>
-          <p:cNvPr id="45" name="Image 0" descr="/Users/tzu/專案/GitHub/20260803-Workshop/course/day-03/instructor/slides/assets/meda-logo.png">    </p:cNvPr>
+          <p:cNvPr id="45" name="Image 0" descr="/private/tmp/20260803-Workshop-day03-analysis-first/course/day-03/instructor/slides/assets/meda-logo.png">    </p:cNvPr>
           <p:cNvPicPr>
             <a:picLocks noChangeAspect="1"/>
           </p:cNvPicPr>
@@ -7306,7 +7306,7 @@
                 <a:ea typeface="Noto Sans TC" pitchFamily="34" charset="-122"/>
                 <a:cs typeface="Noto Sans TC" pitchFamily="34" charset="-120"/>
               </a:rPr>
-              <a:t>操作 04 · 資料處理與索引</a:t>
+              <a:t>操作 4 · 資料處理與索引</a:t>
             </a:r>
             <a:endParaRPr lang="en-US" sz="1000" dirty="0"/>
           </a:p>
@@ -7347,7 +7347,7 @@
                 <a:ea typeface="Noto Sans TC" pitchFamily="34" charset="-122"/>
                 <a:cs typeface="Noto Sans TC" pitchFamily="34" charset="-120"/>
               </a:rPr>
-              <a:t>Step 03｜切成 chunks，建立自己的向量索引</a:t>
+              <a:t>Step 04｜切成 chunks，建立自己的向量索引</a:t>
             </a:r>
             <a:endParaRPr lang="en-US" sz="3200" dirty="0"/>
           </a:p>
@@ -9698,7 +9698,7 @@
       </p:sp>
       <p:pic>
         <p:nvPicPr>
-          <p:cNvPr id="45" name="Image 0" descr="/Users/tzu/專案/GitHub/20260803-Workshop/course/day-03/instructor/slides/assets/meda-logo.png">    </p:cNvPr>
+          <p:cNvPr id="45" name="Image 0" descr="/private/tmp/20260803-Workshop-day03-analysis-first/course/day-03/instructor/slides/assets/meda-logo.png">    </p:cNvPr>
           <p:cNvPicPr>
             <a:picLocks noChangeAspect="1"/>
           </p:cNvPicPr>
@@ -12326,7 +12326,7 @@
       </p:sp>
       <p:pic>
         <p:nvPicPr>
-          <p:cNvPr id="45" name="Image 0" descr="/Users/tzu/專案/GitHub/20260803-Workshop/course/day-03/instructor/slides/assets/meda-logo.png">    </p:cNvPr>
+          <p:cNvPr id="45" name="Image 0" descr="/private/tmp/20260803-Workshop-day03-analysis-first/course/day-03/instructor/slides/assets/meda-logo.png">    </p:cNvPr>
           <p:cNvPicPr>
             <a:picLocks noChangeAspect="1"/>
           </p:cNvPicPr>
@@ -12383,7 +12383,7 @@
                 <a:ea typeface="Noto Sans TC" pitchFamily="34" charset="-122"/>
                 <a:cs typeface="Noto Sans TC" pitchFamily="34" charset="-120"/>
               </a:rPr>
-              <a:t>操作 05 · 05-1 → 05-4</a:t>
+              <a:t>操作 5 · 一段提示詞完成介面</a:t>
             </a:r>
             <a:endParaRPr lang="en-US" sz="1000" dirty="0"/>
           </a:p>
@@ -12424,7 +12424,7 @@
                 <a:ea typeface="Noto Sans TC" pitchFamily="34" charset="-122"/>
                 <a:cs typeface="Noto Sans TC" pitchFamily="34" charset="-120"/>
               </a:rPr>
-              <a:t>Step 04｜用 Codex 建立 Streamlit RAG 問答助手</a:t>
+              <a:t>Step 05｜用 Codex 建立 Streamlit RAG 問答助手</a:t>
             </a:r>
             <a:endParaRPr lang="en-US" sz="3200" dirty="0"/>
           </a:p>
@@ -14672,7 +14672,7 @@
       </p:sp>
       <p:pic>
         <p:nvPicPr>
-          <p:cNvPr id="45" name="Image 0" descr="/Users/tzu/專案/GitHub/20260803-Workshop/course/day-03/instructor/slides/assets/meda-logo.png">    </p:cNvPr>
+          <p:cNvPr id="45" name="Image 0" descr="/private/tmp/20260803-Workshop-day03-analysis-first/course/day-03/instructor/slides/assets/meda-logo.png">    </p:cNvPr>
           <p:cNvPicPr>
             <a:picLocks noChangeAspect="1"/>
           </p:cNvPicPr>
@@ -16687,7 +16687,7 @@
       </p:sp>
       <p:pic>
         <p:nvPicPr>
-          <p:cNvPr id="45" name="Image 0" descr="/Users/tzu/專案/GitHub/20260803-Workshop/course/day-03/instructor/slides/assets/meda-logo.png">    </p:cNvPr>
+          <p:cNvPr id="45" name="Image 0" descr="/private/tmp/20260803-Workshop-day03-analysis-first/course/day-03/instructor/slides/assets/meda-logo.png">    </p:cNvPr>
           <p:cNvPicPr>
             <a:picLocks noChangeAspect="1"/>
           </p:cNvPicPr>
@@ -19040,7 +19040,7 @@
       </p:sp>
       <p:pic>
         <p:nvPicPr>
-          <p:cNvPr id="45" name="Image 0" descr="/Users/tzu/專案/GitHub/20260803-Workshop/course/day-03/instructor/slides/assets/meda-logo.png">    </p:cNvPr>
+          <p:cNvPr id="45" name="Image 0" descr="/private/tmp/20260803-Workshop-day03-analysis-first/course/day-03/instructor/slides/assets/meda-logo.png">    </p:cNvPr>
           <p:cNvPicPr>
             <a:picLocks noChangeAspect="1"/>
           </p:cNvPicPr>
@@ -19138,7 +19138,7 @@
                 <a:ea typeface="Noto Sans TC" pitchFamily="34" charset="-122"/>
                 <a:cs typeface="Noto Sans TC" pitchFamily="34" charset="-120"/>
               </a:rPr>
-              <a:t>Step 05｜問答紀錄：把同一串對話整理成主要主題</a:t>
+              <a:t>問答紀錄：把同一串對話整理成主要主題</a:t>
             </a:r>
             <a:endParaRPr lang="en-US" sz="3200" dirty="0"/>
           </a:p>
@@ -21408,7 +21408,7 @@
       </p:sp>
       <p:pic>
         <p:nvPicPr>
-          <p:cNvPr id="45" name="Image 0" descr="/Users/tzu/專案/GitHub/20260803-Workshop/course/day-03/instructor/slides/assets/meda-logo.png">    </p:cNvPr>
+          <p:cNvPr id="45" name="Image 0" descr="/private/tmp/20260803-Workshop-day03-analysis-first/course/day-03/instructor/slides/assets/meda-logo.png">    </p:cNvPr>
           <p:cNvPicPr>
             <a:picLocks noChangeAspect="1"/>
           </p:cNvPicPr>
@@ -23812,7 +23812,7 @@
       </p:sp>
       <p:pic>
         <p:nvPicPr>
-          <p:cNvPr id="45" name="Image 0" descr="/Users/tzu/專案/GitHub/20260803-Workshop/course/day-03/instructor/slides/assets/meda-logo.png">    </p:cNvPr>
+          <p:cNvPr id="45" name="Image 0" descr="/private/tmp/20260803-Workshop-day03-analysis-first/course/day-03/instructor/slides/assets/meda-logo.png">    </p:cNvPr>
           <p:cNvPicPr>
             <a:picLocks noChangeAspect="1"/>
           </p:cNvPicPr>
@@ -24987,7 +24987,7 @@
                 <a:ea typeface="Noto Sans TC" pitchFamily="34" charset="-122"/>
                 <a:cs typeface="Noto Sans TC" pitchFamily="34" charset="-120"/>
               </a:rPr>
-              <a:t>完成順序：資料與索引 → Codex 建立 Streamlit → RAG 問答與歷程。</a:t>
+              <a:t>完成順序：原始文件 → 分析表 → 索引 → Streamlit 問答與歷程。</a:t>
             </a:r>
             <a:endParaRPr lang="en-US" sz="2000" dirty="0"/>
           </a:p>
@@ -26057,7 +26057,7 @@
       </p:sp>
       <p:pic>
         <p:nvPicPr>
-          <p:cNvPr id="45" name="Image 0" descr="/Users/tzu/專案/GitHub/20260803-Workshop/course/day-03/instructor/slides/assets/meda-logo.png">    </p:cNvPr>
+          <p:cNvPr id="45" name="Image 0" descr="/private/tmp/20260803-Workshop-day03-analysis-first/course/day-03/instructor/slides/assets/meda-logo.png">    </p:cNvPr>
           <p:cNvPicPr>
             <a:picLocks noChangeAspect="1"/>
           </p:cNvPicPr>
@@ -26751,7 +26751,7 @@
                 <a:ea typeface="Noto Sans TC" pitchFamily="34" charset="-122"/>
                 <a:cs typeface="Noto Sans TC" pitchFamily="34" charset="-120"/>
               </a:rPr>
-              <a:t>指定公開資料</a:t>
+              <a:t>四份原始文件</a:t>
             </a:r>
             <a:endParaRPr lang="en-US" sz="1800" dirty="0"/>
           </a:p>
@@ -26792,7 +26792,7 @@
                 <a:ea typeface="Noto Sans TC" pitchFamily="34" charset="-122"/>
                 <a:cs typeface="Noto Sans TC" pitchFamily="34" charset="-120"/>
               </a:rPr>
-              <a:t>依課程給定的四份校務資料，不自行擴大網址。</a:t>
+              <a:t>講師已提供 raw 與來源紀錄，學生不必找網址。</a:t>
             </a:r>
             <a:endParaRPr lang="en-US" sz="1600" dirty="0"/>
           </a:p>
@@ -26861,6 +26861,142 @@
         <p:spPr>
           <a:xfrm>
             <a:off x="6501384" y="1645920"/>
+            <a:ext cx="4626864" cy="320040"/>
+          </a:xfrm>
+          <a:prstGeom prst="rect">
+            <a:avLst/>
+          </a:prstGeom>
+          <a:noFill/>
+          <a:ln/>
+        </p:spPr>
+        <p:txBody>
+          <a:bodyPr wrap="square" lIns="0" tIns="0" rIns="0" bIns="0" rtlCol="0" anchor="ctr">
+            <a:normAutofit/>
+          </a:bodyPr>
+          <a:lstStyle/>
+          <a:p>
+            <a:pPr indent="0" marL="0">
+              <a:buNone/>
+            </a:pPr>
+            <a:r>
+              <a:rPr lang="en-US" sz="1800" b="1" dirty="0">
+                <a:solidFill>
+                  <a:srgbClr val="153E6E"/>
+                </a:solidFill>
+                <a:latin typeface="Noto Sans TC" pitchFamily="34" charset="0"/>
+                <a:ea typeface="Noto Sans TC" pitchFamily="34" charset="-122"/>
+                <a:cs typeface="Noto Sans TC" pitchFamily="34" charset="-120"/>
+              </a:rPr>
+              <a:t>校務文件分析表</a:t>
+            </a:r>
+            <a:endParaRPr lang="en-US" sz="1800" dirty="0"/>
+          </a:p>
+        </p:txBody>
+      </p:sp>
+      <p:sp>
+        <p:nvSpPr>
+          <p:cNvPr id="70" name="Text 67"/>
+          <p:cNvSpPr/>
+          <p:nvPr/>
+        </p:nvSpPr>
+        <p:spPr>
+          <a:xfrm>
+            <a:off x="6501384" y="2112264"/>
+            <a:ext cx="4608576" cy="521208"/>
+          </a:xfrm>
+          <a:prstGeom prst="rect">
+            <a:avLst/>
+          </a:prstGeom>
+          <a:noFill/>
+          <a:ln/>
+        </p:spPr>
+        <p:txBody>
+          <a:bodyPr wrap="square" lIns="0" tIns="0" rIns="0" bIns="0" rtlCol="0" anchor="t">
+            <a:normAutofit/>
+          </a:bodyPr>
+          <a:lstStyle/>
+          <a:p>
+            <a:pPr indent="0" marL="0">
+              <a:buNone/>
+            </a:pPr>
+            <a:r>
+              <a:rPr lang="en-US" sz="1600" dirty="0">
+                <a:solidFill>
+                  <a:srgbClr val="49657A"/>
+                </a:solidFill>
+                <a:latin typeface="Noto Sans TC" pitchFamily="34" charset="0"/>
+                <a:ea typeface="Noto Sans TC" pitchFamily="34" charset="-122"/>
+                <a:cs typeface="Noto Sans TC" pitchFamily="34" charset="-120"/>
+              </a:rPr>
+              <a:t>分開原文、AI 解讀、適用條件與不確定處。</a:t>
+            </a:r>
+            <a:endParaRPr lang="en-US" sz="1600" dirty="0"/>
+          </a:p>
+        </p:txBody>
+      </p:sp>
+      <p:sp>
+        <p:nvSpPr>
+          <p:cNvPr id="71" name="Shape 68"/>
+          <p:cNvSpPr/>
+          <p:nvPr/>
+        </p:nvSpPr>
+        <p:spPr>
+          <a:xfrm>
+            <a:off x="685800" y="3264408"/>
+            <a:ext cx="5084064" cy="1389888"/>
+          </a:xfrm>
+          <a:prstGeom prst="roundRect">
+            <a:avLst>
+              <a:gd name="adj" fmla="val 5263"/>
+            </a:avLst>
+          </a:prstGeom>
+          <a:solidFill>
+            <a:srgbClr val="FFFFFF"/>
+          </a:solidFill>
+          <a:ln w="12700">
+            <a:solidFill>
+              <a:srgbClr val="FFFFFF">
+                <a:alpha val="0"/>
+              </a:srgbClr>
+            </a:solidFill>
+            <a:prstDash val="solid"/>
+          </a:ln>
+        </p:spPr>
+      </p:sp>
+      <p:sp>
+        <p:nvSpPr>
+          <p:cNvPr id="72" name="Shape 69"/>
+          <p:cNvSpPr/>
+          <p:nvPr/>
+        </p:nvSpPr>
+        <p:spPr>
+          <a:xfrm>
+            <a:off x="685800" y="3264408"/>
+            <a:ext cx="91440" cy="1389888"/>
+          </a:xfrm>
+          <a:prstGeom prst="rect">
+            <a:avLst/>
+          </a:prstGeom>
+          <a:solidFill>
+            <a:srgbClr val="E8B849"/>
+          </a:solidFill>
+          <a:ln w="12700">
+            <a:solidFill>
+              <a:srgbClr val="E8B849"/>
+            </a:solidFill>
+            <a:prstDash val="solid"/>
+          </a:ln>
+        </p:spPr>
+      </p:sp>
+      <p:sp>
+        <p:nvSpPr>
+          <p:cNvPr id="73" name="Text 70"/>
+          <p:cNvSpPr/>
+          <p:nvPr/>
+        </p:nvSpPr>
+        <p:spPr>
+          <a:xfrm>
+            <a:off x="941832" y="3493008"/>
             <a:ext cx="4626864" cy="320040"/>
           </a:xfrm>
           <a:prstGeom prst="rect">
@@ -26895,13 +27031,13 @@
       </p:sp>
       <p:sp>
         <p:nvSpPr>
-          <p:cNvPr id="70" name="Text 67"/>
-          <p:cNvSpPr/>
-          <p:nvPr/>
-        </p:nvSpPr>
-        <p:spPr>
-          <a:xfrm>
-            <a:off x="6501384" y="2112264"/>
+          <p:cNvPr id="74" name="Text 71"/>
+          <p:cNvSpPr/>
+          <p:nvPr/>
+        </p:nvSpPr>
+        <p:spPr>
+          <a:xfrm>
+            <a:off x="941832" y="3959352"/>
             <a:ext cx="4608576" cy="521208"/>
           </a:xfrm>
           <a:prstGeom prst="rect">
@@ -26928,143 +27064,7 @@
                 <a:ea typeface="Noto Sans TC" pitchFamily="34" charset="-122"/>
                 <a:cs typeface="Noto Sans TC" pitchFamily="34" charset="-120"/>
               </a:rPr>
-              <a:t>保留 raw、Markdown、品質結果、chunks 與向量索引。</a:t>
-            </a:r>
-            <a:endParaRPr lang="en-US" sz="1600" dirty="0"/>
-          </a:p>
-        </p:txBody>
-      </p:sp>
-      <p:sp>
-        <p:nvSpPr>
-          <p:cNvPr id="71" name="Shape 68"/>
-          <p:cNvSpPr/>
-          <p:nvPr/>
-        </p:nvSpPr>
-        <p:spPr>
-          <a:xfrm>
-            <a:off x="685800" y="3264408"/>
-            <a:ext cx="5084064" cy="1389888"/>
-          </a:xfrm>
-          <a:prstGeom prst="roundRect">
-            <a:avLst>
-              <a:gd name="adj" fmla="val 5263"/>
-            </a:avLst>
-          </a:prstGeom>
-          <a:solidFill>
-            <a:srgbClr val="FFFFFF"/>
-          </a:solidFill>
-          <a:ln w="12700">
-            <a:solidFill>
-              <a:srgbClr val="FFFFFF">
-                <a:alpha val="0"/>
-              </a:srgbClr>
-            </a:solidFill>
-            <a:prstDash val="solid"/>
-          </a:ln>
-        </p:spPr>
-      </p:sp>
-      <p:sp>
-        <p:nvSpPr>
-          <p:cNvPr id="72" name="Shape 69"/>
-          <p:cNvSpPr/>
-          <p:nvPr/>
-        </p:nvSpPr>
-        <p:spPr>
-          <a:xfrm>
-            <a:off x="685800" y="3264408"/>
-            <a:ext cx="91440" cy="1389888"/>
-          </a:xfrm>
-          <a:prstGeom prst="rect">
-            <a:avLst/>
-          </a:prstGeom>
-          <a:solidFill>
-            <a:srgbClr val="E8B849"/>
-          </a:solidFill>
-          <a:ln w="12700">
-            <a:solidFill>
-              <a:srgbClr val="E8B849"/>
-            </a:solidFill>
-            <a:prstDash val="solid"/>
-          </a:ln>
-        </p:spPr>
-      </p:sp>
-      <p:sp>
-        <p:nvSpPr>
-          <p:cNvPr id="73" name="Text 70"/>
-          <p:cNvSpPr/>
-          <p:nvPr/>
-        </p:nvSpPr>
-        <p:spPr>
-          <a:xfrm>
-            <a:off x="941832" y="3493008"/>
-            <a:ext cx="4626864" cy="320040"/>
-          </a:xfrm>
-          <a:prstGeom prst="rect">
-            <a:avLst/>
-          </a:prstGeom>
-          <a:noFill/>
-          <a:ln/>
-        </p:spPr>
-        <p:txBody>
-          <a:bodyPr wrap="square" lIns="0" tIns="0" rIns="0" bIns="0" rtlCol="0" anchor="ctr">
-            <a:normAutofit/>
-          </a:bodyPr>
-          <a:lstStyle/>
-          <a:p>
-            <a:pPr indent="0" marL="0">
-              <a:buNone/>
-            </a:pPr>
-            <a:r>
-              <a:rPr lang="en-US" sz="1800" b="1" dirty="0">
-                <a:solidFill>
-                  <a:srgbClr val="153E6E"/>
-                </a:solidFill>
-                <a:latin typeface="Noto Sans TC" pitchFamily="34" charset="0"/>
-                <a:ea typeface="Noto Sans TC" pitchFamily="34" charset="-122"/>
-                <a:cs typeface="Noto Sans TC" pitchFamily="34" charset="-120"/>
-              </a:rPr>
-              <a:t>Codex 建立介面</a:t>
-            </a:r>
-            <a:endParaRPr lang="en-US" sz="1800" dirty="0"/>
-          </a:p>
-        </p:txBody>
-      </p:sp>
-      <p:sp>
-        <p:nvSpPr>
-          <p:cNvPr id="74" name="Text 71"/>
-          <p:cNvSpPr/>
-          <p:nvPr/>
-        </p:nvSpPr>
-        <p:spPr>
-          <a:xfrm>
-            <a:off x="941832" y="3959352"/>
-            <a:ext cx="4608576" cy="521208"/>
-          </a:xfrm>
-          <a:prstGeom prst="rect">
-            <a:avLst/>
-          </a:prstGeom>
-          <a:noFill/>
-          <a:ln/>
-        </p:spPr>
-        <p:txBody>
-          <a:bodyPr wrap="square" lIns="0" tIns="0" rIns="0" bIns="0" rtlCol="0" anchor="t">
-            <a:normAutofit/>
-          </a:bodyPr>
-          <a:lstStyle/>
-          <a:p>
-            <a:pPr indent="0" marL="0">
-              <a:buNone/>
-            </a:pPr>
-            <a:r>
-              <a:rPr lang="en-US" sz="1600" dirty="0">
-                <a:solidFill>
-                  <a:srgbClr val="49657A"/>
-                </a:solidFill>
-                <a:latin typeface="Noto Sans TC" pitchFamily="34" charset="0"/>
-                <a:ea typeface="Noto Sans TC" pitchFamily="34" charset="-122"/>
-                <a:cs typeface="Noto Sans TC" pitchFamily="34" charset="-120"/>
-              </a:rPr>
-              <a:t>從空白建立 Streamlit 聊天頁、開新對話與問答紀錄。</a:t>
+              <a:t>Markdown、品質結果、chunks 與向量索引。</a:t>
             </a:r>
             <a:endParaRPr lang="en-US" sz="1600" dirty="0"/>
           </a:p>
@@ -27241,7 +27241,7 @@
                 <a:ea typeface="Noto Sans TC" pitchFamily="34" charset="-122"/>
                 <a:cs typeface="Noto Sans TC" pitchFamily="34" charset="-120"/>
               </a:rPr>
-              <a:t>完成順序不能倒過來：資料 → 索引 → Streamlit → RAG 問答與歷程。</a:t>
+              <a:t>完成順序不能倒過來：原始文件 → 分析表 → 索引 → Streamlit 問答與歷程。</a:t>
             </a:r>
             <a:endParaRPr lang="en-US" sz="1900" dirty="0"/>
           </a:p>
@@ -28270,7 +28270,7 @@
       </p:sp>
       <p:pic>
         <p:nvPicPr>
-          <p:cNvPr id="45" name="Image 0" descr="/Users/tzu/專案/GitHub/20260803-Workshop/course/day-03/instructor/slides/assets/meda-logo.png">    </p:cNvPr>
+          <p:cNvPr id="45" name="Image 0" descr="/private/tmp/20260803-Workshop-day03-analysis-first/course/day-03/instructor/slides/assets/meda-logo.png">    </p:cNvPr>
           <p:cNvPicPr>
             <a:picLocks noChangeAspect="1"/>
           </p:cNvPicPr>
@@ -29170,7 +29170,7 @@
                 <a:ea typeface="Noto Sans TC" pitchFamily="34" charset="-122"/>
                 <a:cs typeface="Noto Sans TC" pitchFamily="34" charset="-120"/>
               </a:rPr>
-              <a:t>固定資料範圍</a:t>
+              <a:t>讀懂來源資料</a:t>
             </a:r>
             <a:endParaRPr lang="en-US" sz="1400" dirty="0"/>
           </a:p>
@@ -29211,7 +29211,7 @@
                 <a:ea typeface="Noto Sans TC" pitchFamily="34" charset="-122"/>
                 <a:cs typeface="Noto Sans TC" pitchFamily="34" charset="-120"/>
               </a:rPr>
-              <a:t>四份指定來源</a:t>
+              <a:t>raw + manifest</a:t>
             </a:r>
             <a:endParaRPr lang="en-US" sz="1000" dirty="0"/>
           </a:p>
@@ -29341,7 +29341,7 @@
                 <a:ea typeface="Noto Sans TC" pitchFamily="34" charset="-122"/>
                 <a:cs typeface="Noto Sans TC" pitchFamily="34" charset="-120"/>
               </a:rPr>
-              <a:t>取得、解析、檢查</a:t>
+              <a:t>解析與品質檢查</a:t>
             </a:r>
             <a:endParaRPr lang="en-US" sz="1400" dirty="0"/>
           </a:p>
@@ -29512,7 +29512,7 @@
                 <a:ea typeface="Noto Sans TC" pitchFamily="34" charset="-122"/>
                 <a:cs typeface="Noto Sans TC" pitchFamily="34" charset="-120"/>
               </a:rPr>
-              <a:t>切塊與索引</a:t>
+              <a:t>建立分析表</a:t>
             </a:r>
             <a:endParaRPr lang="en-US" sz="1400" dirty="0"/>
           </a:p>
@@ -29553,7 +29553,7 @@
                 <a:ea typeface="Noto Sans TC" pitchFamily="34" charset="-122"/>
                 <a:cs typeface="Noto Sans TC" pitchFamily="34" charset="-120"/>
               </a:rPr>
-              <a:t>chunks → vectors</a:t>
+              <a:t>原文 → AI 解讀</a:t>
             </a:r>
             <a:endParaRPr lang="en-US" sz="1000" dirty="0"/>
           </a:p>
@@ -29683,7 +29683,7 @@
                 <a:ea typeface="Noto Sans TC" pitchFamily="34" charset="-122"/>
                 <a:cs typeface="Noto Sans TC" pitchFamily="34" charset="-120"/>
               </a:rPr>
-              <a:t>建立 Streamlit</a:t>
+              <a:t>索引與 Streamlit</a:t>
             </a:r>
             <a:endParaRPr lang="en-US" sz="1400" dirty="0"/>
           </a:p>
@@ -30924,7 +30924,7 @@
       </p:sp>
       <p:pic>
         <p:nvPicPr>
-          <p:cNvPr id="45" name="Image 0" descr="/Users/tzu/專案/GitHub/20260803-Workshop/course/day-03/instructor/slides/assets/meda-logo.png">    </p:cNvPr>
+          <p:cNvPr id="45" name="Image 0" descr="/private/tmp/20260803-Workshop-day03-analysis-first/course/day-03/instructor/slides/assets/meda-logo.png">    </p:cNvPr>
           <p:cNvPicPr>
             <a:picLocks noChangeAspect="1"/>
           </p:cNvPicPr>
@@ -31659,7 +31659,7 @@
                 <a:ea typeface="Noto Sans TC" pitchFamily="34" charset="-122"/>
                 <a:cs typeface="Noto Sans TC" pitchFamily="34" charset="-120"/>
               </a:rPr>
-              <a:t>指定資料</a:t>
+              <a:t>講師提供來源</a:t>
             </a:r>
             <a:endParaRPr lang="en-US" sz="2100" dirty="0"/>
           </a:p>
@@ -31700,7 +31700,7 @@
                 <a:ea typeface="Noto Sans TC" pitchFamily="34" charset="-122"/>
                 <a:cs typeface="Noto Sans TC" pitchFamily="34" charset="-120"/>
               </a:rPr>
-              <a:t>依序取得四份課程指定的公開文件</a:t>
+              <a:t>四份 raw 文件與來源紀錄已在 starter</a:t>
             </a:r>
             <a:endParaRPr lang="en-US" sz="1350" dirty="0"/>
           </a:p>
@@ -31877,7 +31877,7 @@
                 <a:ea typeface="Noto Sans TC" pitchFamily="34" charset="-122"/>
                 <a:cs typeface="Noto Sans TC" pitchFamily="34" charset="-120"/>
               </a:rPr>
-              <a:t>資料處理</a:t>
+              <a:t>生成式 AI 分析</a:t>
             </a:r>
             <a:endParaRPr lang="en-US" sz="2100" dirty="0"/>
           </a:p>
@@ -31918,7 +31918,7 @@
                 <a:ea typeface="Noto Sans TC" pitchFamily="34" charset="-122"/>
                 <a:cs typeface="Noto Sans TC" pitchFamily="34" charset="-120"/>
               </a:rPr>
-              <a:t>raw、Markdown、品質、chunks 與索引</a:t>
+              <a:t>Markdown、品質、分析表、chunks 與索引</a:t>
             </a:r>
             <a:endParaRPr lang="en-US" sz="1350" dirty="0"/>
           </a:p>
@@ -32177,7 +32177,7 @@
                 <a:ea typeface="Noto Sans TC" pitchFamily="34" charset="-122"/>
                 <a:cs typeface="Noto Sans TC" pitchFamily="34" charset="-120"/>
               </a:rPr>
-              <a:t>關鍵順序：先取得資料與索引，最後才建立問答介面。</a:t>
+              <a:t>關鍵順序：先分析文件，再建立索引與問答介面。</a:t>
             </a:r>
             <a:endParaRPr lang="en-US" sz="2200" dirty="0"/>
           </a:p>
@@ -33206,7 +33206,7 @@
       </p:sp>
       <p:pic>
         <p:nvPicPr>
-          <p:cNvPr id="45" name="Image 0" descr="/Users/tzu/專案/GitHub/20260803-Workshop/course/day-03/instructor/slides/assets/meda-logo.png">    </p:cNvPr>
+          <p:cNvPr id="45" name="Image 0" descr="/private/tmp/20260803-Workshop-day03-analysis-first/course/day-03/instructor/slides/assets/meda-logo.png">    </p:cNvPr>
           <p:cNvPicPr>
             <a:picLocks noChangeAspect="1"/>
           </p:cNvPicPr>
@@ -35283,7 +35283,7 @@
       </p:sp>
       <p:pic>
         <p:nvPicPr>
-          <p:cNvPr id="45" name="Image 0" descr="/Users/tzu/專案/GitHub/20260803-Workshop/course/day-03/instructor/slides/assets/meda-logo.png">    </p:cNvPr>
+          <p:cNvPr id="45" name="Image 0" descr="/private/tmp/20260803-Workshop-day03-analysis-first/course/day-03/instructor/slides/assets/meda-logo.png">    </p:cNvPr>
           <p:cNvPicPr>
             <a:picLocks noChangeAspect="1"/>
           </p:cNvPicPr>
@@ -37904,7 +37904,7 @@
       </p:sp>
       <p:pic>
         <p:nvPicPr>
-          <p:cNvPr id="45" name="Image 0" descr="/Users/tzu/專案/GitHub/20260803-Workshop/course/day-03/instructor/slides/assets/meda-logo.png">    </p:cNvPr>
+          <p:cNvPr id="45" name="Image 0" descr="/private/tmp/20260803-Workshop-day03-analysis-first/course/day-03/instructor/slides/assets/meda-logo.png">    </p:cNvPr>
           <p:cNvPicPr>
             <a:picLocks noChangeAspect="1"/>
           </p:cNvPicPr>
@@ -37961,7 +37961,7 @@
                 <a:ea typeface="Noto Sans TC" pitchFamily="34" charset="-122"/>
                 <a:cs typeface="Noto Sans TC" pitchFamily="34" charset="-120"/>
               </a:rPr>
-              <a:t>操作 01 · 00-CREATE-PROJECT-AND-START-URL</a:t>
+              <a:t>操作 1 · 環境與來源確認</a:t>
             </a:r>
             <a:endParaRPr lang="en-US" sz="1000" dirty="0"/>
           </a:p>
@@ -38002,7 +38002,7 @@
                 <a:ea typeface="Noto Sans TC" pitchFamily="34" charset="-122"/>
                 <a:cs typeface="Noto Sans TC" pitchFamily="34" charset="-120"/>
               </a:rPr>
-              <a:t>Step 00｜建立個人專案，再寫入固定資料範圍</a:t>
+              <a:t>Step 01｜讀取講師提供的四份原始文件</a:t>
             </a:r>
             <a:endParaRPr lang="en-US" sz="3200" dirty="0"/>
           </a:p>
@@ -38760,7 +38760,7 @@
                 <a:ea typeface="Noto Sans TC" pitchFamily="34" charset="-122"/>
                 <a:cs typeface="Noto Sans TC" pitchFamily="34" charset="-120"/>
               </a:rPr>
-              <a:t>預期產物</a:t>
+              <a:t>starter 已備妥</a:t>
             </a:r>
             <a:endParaRPr lang="en-US" sz="2000" dirty="0"/>
           </a:p>
@@ -38774,8 +38774,8 @@
         </p:nvSpPr>
         <p:spPr>
           <a:xfrm>
-            <a:off x="6931152" y="2331720"/>
-            <a:ext cx="4069080" cy="2011680"/>
+            <a:off x="6931152" y="2194560"/>
+            <a:ext cx="4069080" cy="2331720"/>
           </a:xfrm>
           <a:prstGeom prst="rect">
             <a:avLst/>
@@ -38801,7 +38801,7 @@
                 <a:ea typeface="Consolas" pitchFamily="34" charset="-122"/>
                 <a:cs typeface="Consolas" pitchFamily="34" charset="-120"/>
               </a:rPr>
-              <a:t>my-project/</a:t>
+              <a:t>data/raw/      原始文件</a:t>
             </a:r>
             <a:endParaRPr lang="en-US" sz="1500" dirty="0"/>
           </a:p>
@@ -38818,7 +38818,7 @@
                 <a:ea typeface="Consolas" pitchFamily="34" charset="-122"/>
                 <a:cs typeface="Consolas" pitchFamily="34" charset="-120"/>
               </a:rPr>
-              <a:t>├── data/raw/</a:t>
+              <a:t>data/manifests/ 來源紀錄</a:t>
             </a:r>
             <a:endParaRPr lang="en-US" sz="1500" dirty="0"/>
           </a:p>
@@ -38835,7 +38835,7 @@
                 <a:ea typeface="Consolas" pitchFamily="34" charset="-122"/>
                 <a:cs typeface="Consolas" pitchFamily="34" charset="-120"/>
               </a:rPr>
-              <a:t>├── data/manifests/</a:t>
+              <a:t>data/markdown/  轉換結果</a:t>
             </a:r>
             <a:endParaRPr lang="en-US" sz="1500" dirty="0"/>
           </a:p>
@@ -38852,7 +38852,7 @@
                 <a:ea typeface="Consolas" pitchFamily="34" charset="-122"/>
                 <a:cs typeface="Consolas" pitchFamily="34" charset="-120"/>
               </a:rPr>
-              <a:t>├── data/markdown/</a:t>
+              <a:t>analysis/       分析表</a:t>
             </a:r>
             <a:endParaRPr lang="en-US" sz="1500" dirty="0"/>
           </a:p>
@@ -38869,7 +38869,7 @@
                 <a:ea typeface="Consolas" pitchFamily="34" charset="-122"/>
                 <a:cs typeface="Consolas" pitchFamily="34" charset="-120"/>
               </a:rPr>
-              <a:t>├── data/processed/</a:t>
+              <a:t>data/processed/ 索引</a:t>
             </a:r>
             <a:endParaRPr lang="en-US" sz="1500" dirty="0"/>
           </a:p>
@@ -38886,7 +38886,7 @@
                 <a:ea typeface="Consolas" pitchFamily="34" charset="-122"/>
                 <a:cs typeface="Consolas" pitchFamily="34" charset="-120"/>
               </a:rPr>
-              <a:t>├── analysis/  rag/  feedback/</a:t>
+              <a:t>rag/  feedback/  介面與歷程</a:t>
             </a:r>
             <a:endParaRPr lang="en-US" sz="1500" dirty="0"/>
           </a:p>
@@ -39915,7 +39915,7 @@
       </p:sp>
       <p:pic>
         <p:nvPicPr>
-          <p:cNvPr id="45" name="Image 0" descr="/Users/tzu/專案/GitHub/20260803-Workshop/course/day-03/instructor/slides/assets/meda-logo.png">    </p:cNvPr>
+          <p:cNvPr id="45" name="Image 0" descr="/private/tmp/20260803-Workshop-day03-analysis-first/course/day-03/instructor/slides/assets/meda-logo.png">    </p:cNvPr>
           <p:cNvPicPr>
             <a:picLocks noChangeAspect="1"/>
           </p:cNvPicPr>
@@ -39972,7 +39972,7 @@
                 <a:ea typeface="Noto Sans TC" pitchFamily="34" charset="-122"/>
                 <a:cs typeface="Noto Sans TC" pitchFamily="34" charset="-120"/>
               </a:rPr>
-              <a:t>操作 02 · 固定來源批次處理</a:t>
+              <a:t>操作 2 · MARKITDOWN 轉換</a:t>
             </a:r>
             <a:endParaRPr lang="en-US" sz="1000" dirty="0"/>
           </a:p>
@@ -40013,7 +40013,7 @@
                 <a:ea typeface="Noto Sans TC" pitchFamily="34" charset="-122"/>
                 <a:cs typeface="Noto Sans TC" pitchFamily="34" charset="-120"/>
               </a:rPr>
-              <a:t>Step 01｜一次批次依序處理四份指定資料</a:t>
+              <a:t>Step 02｜轉換四份原始文件並做品質檢查</a:t>
             </a:r>
             <a:endParaRPr lang="en-US" sz="3200" dirty="0"/>
           </a:p>
@@ -40077,7 +40077,7 @@
                 <a:ea typeface="Noto Sans TC" pitchFamily="34" charset="-122"/>
                 <a:cs typeface="Noto Sans TC" pitchFamily="34" charset="-120"/>
               </a:rPr>
-              <a:t>CRAWL</a:t>
+              <a:t>PARSE</a:t>
             </a:r>
             <a:endParaRPr lang="en-US" sz="850" dirty="0"/>
           </a:p>
@@ -40621,7 +40621,7 @@
                 <a:ea typeface="Noto Sans TC" pitchFamily="34" charset="-122"/>
                 <a:cs typeface="Noto Sans TC" pitchFamily="34" charset="-120"/>
               </a:rPr>
-              <a:t>確認規範</a:t>
+              <a:t>讀取 manifest</a:t>
             </a:r>
             <a:endParaRPr lang="en-US" sz="1200" dirty="0"/>
           </a:p>
@@ -40662,7 +40662,7 @@
                 <a:ea typeface="Noto Sans TC" pitchFamily="34" charset="-122"/>
                 <a:cs typeface="Noto Sans TC" pitchFamily="34" charset="-120"/>
               </a:rPr>
-              <a:t>只確認該來源</a:t>
+              <a:t>確認四份來源</a:t>
             </a:r>
             <a:endParaRPr lang="en-US" sz="880" dirty="0"/>
           </a:p>
@@ -40679,7 +40679,7 @@
                 <a:ea typeface="Noto Sans TC" pitchFamily="34" charset="-122"/>
                 <a:cs typeface="Noto Sans TC" pitchFamily="34" charset="-120"/>
               </a:rPr>
-              <a:t>是否可公開取得</a:t>
+              <a:t>與原始檔</a:t>
             </a:r>
             <a:endParaRPr lang="en-US" sz="880" dirty="0"/>
           </a:p>
@@ -40786,7 +40786,7 @@
                 <a:ea typeface="Noto Sans TC" pitchFamily="34" charset="-122"/>
                 <a:cs typeface="Noto Sans TC" pitchFamily="34" charset="-120"/>
               </a:rPr>
-              <a:t>取得原始檔</a:t>
+              <a:t>保留原始檔</a:t>
             </a:r>
             <a:endParaRPr lang="en-US" sz="1200" dirty="0"/>
           </a:p>
@@ -41116,7 +41116,7 @@
                 <a:ea typeface="Noto Sans TC" pitchFamily="34" charset="-122"/>
                 <a:cs typeface="Noto Sans TC" pitchFamily="34" charset="-120"/>
               </a:rPr>
-              <a:t>結果總表</a:t>
+              <a:t>品質結果</a:t>
             </a:r>
             <a:endParaRPr lang="en-US" sz="1200" dirty="0"/>
           </a:p>
@@ -41157,7 +41157,7 @@
                 <a:ea typeface="Noto Sans TC" pitchFamily="34" charset="-122"/>
                 <a:cs typeface="Noto Sans TC" pitchFamily="34" charset="-120"/>
               </a:rPr>
-              <a:t>取得、解析、品質</a:t>
+              <a:t>可分析或</a:t>
             </a:r>
             <a:endParaRPr lang="en-US" sz="880" dirty="0"/>
           </a:p>
@@ -41174,7 +41174,7 @@
                 <a:ea typeface="Noto Sans TC" pitchFamily="34" charset="-122"/>
                 <a:cs typeface="Noto Sans TC" pitchFamily="34" charset="-120"/>
               </a:rPr>
-              <a:t>逐份留下結果</a:t>
+              <a:t>人工查看</a:t>
             </a:r>
             <a:endParaRPr lang="en-US" sz="880" dirty="0"/>
           </a:p>
@@ -42203,7 +42203,7 @@
       </p:sp>
       <p:pic>
         <p:nvPicPr>
-          <p:cNvPr id="45" name="Image 0" descr="/Users/tzu/專案/GitHub/20260803-Workshop/course/day-03/instructor/slides/assets/meda-logo.png">    </p:cNvPr>
+          <p:cNvPr id="45" name="Image 0" descr="/private/tmp/20260803-Workshop-day03-analysis-first/course/day-03/instructor/slides/assets/meda-logo.png">    </p:cNvPr>
           <p:cNvPicPr>
             <a:picLocks noChangeAspect="1"/>
           </p:cNvPicPr>
@@ -42260,7 +42260,7 @@
                 <a:ea typeface="Noto Sans TC" pitchFamily="34" charset="-122"/>
                 <a:cs typeface="Noto Sans TC" pitchFamily="34" charset="-120"/>
               </a:rPr>
-              <a:t>操作 03 · MARKITDOWN 與來源紀錄</a:t>
+              <a:t>操作 3 · 原文與 AI 解讀分開</a:t>
             </a:r>
             <a:endParaRPr lang="en-US" sz="1000" dirty="0"/>
           </a:p>
@@ -42301,7 +42301,7 @@
                 <a:ea typeface="Noto Sans TC" pitchFamily="34" charset="-122"/>
                 <a:cs typeface="Noto Sans TC" pitchFamily="34" charset="-120"/>
               </a:rPr>
-              <a:t>Step 02｜把自己的原始資料轉成可用文字</a:t>
+              <a:t>Step 03｜先做校務文件分析表，再建立搜尋索引</a:t>
             </a:r>
             <a:endParaRPr lang="en-US" sz="3200" dirty="0"/>
           </a:p>
@@ -42365,7 +42365,7 @@
                 <a:ea typeface="Noto Sans TC" pitchFamily="34" charset="-122"/>
                 <a:cs typeface="Noto Sans TC" pitchFamily="34" charset="-120"/>
               </a:rPr>
-              <a:t>PARSE</a:t>
+              <a:t>ANALYZE</a:t>
             </a:r>
             <a:endParaRPr lang="en-US" sz="850" dirty="0"/>
           </a:p>
@@ -42897,7 +42897,7 @@
                 <a:ea typeface="Noto Sans TC" pitchFamily="34" charset="-122"/>
                 <a:cs typeface="Noto Sans TC" pitchFamily="34" charset="-120"/>
               </a:rPr>
-              <a:t>原始資料</a:t>
+              <a:t>文件明確寫了什麼</a:t>
             </a:r>
             <a:endParaRPr lang="en-US" sz="1800" dirty="0"/>
           </a:p>
@@ -42938,7 +42938,7 @@
                 <a:ea typeface="Noto Sans TC" pitchFamily="34" charset="-122"/>
                 <a:cs typeface="Noto Sans TC" pitchFamily="34" charset="-120"/>
               </a:rPr>
-              <a:t>每份成功來源保留 raw 檔。</a:t>
+              <a:t>保留可回查的原文、年度、對象與來源段落。</a:t>
             </a:r>
             <a:endParaRPr lang="en-US" sz="1600" dirty="0"/>
           </a:p>
@@ -42961,7 +42961,7 @@
                 <a:ea typeface="Noto Sans TC" pitchFamily="34" charset="-122"/>
                 <a:cs typeface="Noto Sans TC" pitchFamily="34" charset="-120"/>
               </a:rPr>
-              <a:t>HTML、DOCX、PDF 都不直接拿去聊天。</a:t>
+              <a:t>不把推論寫成規定。</a:t>
             </a:r>
             <a:endParaRPr lang="en-US" sz="1600" dirty="0"/>
           </a:p>
@@ -43056,7 +43056,7 @@
                 <a:ea typeface="Noto Sans TC" pitchFamily="34" charset="-122"/>
                 <a:cs typeface="Noto Sans TC" pitchFamily="34" charset="-120"/>
               </a:rPr>
-              <a:t>轉成 Markdown</a:t>
+              <a:t>AI 摘要或分類</a:t>
             </a:r>
             <a:endParaRPr lang="en-US" sz="1800" dirty="0"/>
           </a:p>
@@ -43097,7 +43097,7 @@
                 <a:ea typeface="Noto Sans TC" pitchFamily="34" charset="-122"/>
                 <a:cs typeface="Noto Sans TC" pitchFamily="34" charset="-120"/>
               </a:rPr>
-              <a:t>透過 Codex 的 MarkItDown MCP，轉為可閱讀、可搜尋的 Markdown。</a:t>
+              <a:t>AI 協助整理學生行動、主題與重點。</a:t>
             </a:r>
             <a:endParaRPr lang="en-US" sz="1600" dirty="0"/>
           </a:p>
@@ -43120,7 +43120,7 @@
                 <a:ea typeface="Noto Sans TC" pitchFamily="34" charset="-122"/>
                 <a:cs typeface="Noto Sans TC" pitchFamily="34" charset="-120"/>
               </a:rPr>
-              <a:t>不修改 data/raw。</a:t>
+              <a:t>明確標示這是 AI 解讀。</a:t>
             </a:r>
             <a:endParaRPr lang="en-US" sz="1600" dirty="0"/>
           </a:p>
@@ -43215,7 +43215,7 @@
                 <a:ea typeface="Noto Sans TC" pitchFamily="34" charset="-122"/>
                 <a:cs typeface="Noto Sans TC" pitchFamily="34" charset="-120"/>
               </a:rPr>
-              <a:t>品質與來源</a:t>
+              <a:t>不確定處與索引</a:t>
             </a:r>
             <a:endParaRPr lang="en-US" sz="1800" dirty="0"/>
           </a:p>
@@ -43256,30 +43256,7 @@
                 <a:ea typeface="Noto Sans TC" pitchFamily="34" charset="-122"/>
                 <a:cs typeface="Noto Sans TC" pitchFamily="34" charset="-120"/>
               </a:rPr>
-              <a:t>文件識別、URL、取得時間與品質結果都保留。</a:t>
-            </a:r>
-            <a:endParaRPr lang="en-US" sz="1600" dirty="0"/>
-          </a:p>
-          <a:p>
-            <a:pPr indent="0" marL="0">
-              <a:buNone/>
-            </a:pPr>
-            <a:endParaRPr lang="en-US" sz="1600" dirty="0"/>
-          </a:p>
-          <a:p>
-            <a:pPr indent="0" marL="0">
-              <a:buNone/>
-            </a:pPr>
-            <a:r>
-              <a:rPr lang="en-US" sz="1600" dirty="0">
-                <a:solidFill>
-                  <a:srgbClr val="49657A"/>
-                </a:solidFill>
-                <a:latin typeface="Noto Sans TC" pitchFamily="34" charset="0"/>
-                <a:ea typeface="Noto Sans TC" pitchFamily="34" charset="-122"/>
-                <a:cs typeface="Noto Sans TC" pitchFamily="34" charset="-120"/>
-              </a:rPr>
-              <a:t>這些會變成之後的引用。</a:t>
+              <a:t>條件不足就標示不確定；只有可用文字才切成 chunks。</a:t>
             </a:r>
             <a:endParaRPr lang="en-US" sz="1600" dirty="0"/>
           </a:p>
@@ -43320,7 +43297,7 @@
                 <a:ea typeface="Noto Sans TC" pitchFamily="34" charset="-122"/>
                 <a:cs typeface="Noto Sans TC" pitchFamily="34" charset="-120"/>
               </a:rPr>
-              <a:t>先爬取 → 再解析：MarkItDown 不是網站爬蟲。</a:t>
+              <a:t>分析表是主要成果；索引與問答助手用來驗證它。</a:t>
             </a:r>
             <a:endParaRPr lang="en-US" sz="2000" dirty="0"/>
           </a:p>

</xml_diff>